<commit_message>
chore(templates): recharger les layouts bleus et calibrer le planning live.
Applique les retouches de mise en page des templates 8/12/16/20/24, régénère tous les layout.json live et aligne les zones TERMINÉ sur le PDF Engine pour éviter la dérive ligne par ligne.

Co-authored-by: Cursor <cursoragent@cursor.com>
</commit_message>
<xml_diff>
--- a/templates bleus/Template_12_1J.pptx
+++ b/templates bleus/Template_12_1J.pptx
@@ -216,7 +216,7 @@
           <a:p>
             <a:fld id="{7758DB49-402F-FB41-B58E-980CBE386162}" type="datetimeFigureOut">
               <a:rPr lang="fr-FR" smtClean="0"/>
-              <a:t>02/07/2026</a:t>
+              <a:t>07/07/2026</a:t>
             </a:fld>
             <a:endParaRPr lang="fr-FR"/>
           </a:p>
@@ -662,7 +662,7 @@
           <a:p>
             <a:fld id="{5BCAD085-E8A6-8845-BD4E-CB4CCA059FC4}" type="datetimeFigureOut">
               <a:rPr lang="en-US" smtClean="0"/>
-              <a:t>7/2/26</a:t>
+              <a:t>7/7/26</a:t>
             </a:fld>
             <a:endParaRPr lang="en-US"/>
           </a:p>
@@ -830,7 +830,7 @@
           <a:p>
             <a:fld id="{5BCAD085-E8A6-8845-BD4E-CB4CCA059FC4}" type="datetimeFigureOut">
               <a:rPr lang="en-US" smtClean="0"/>
-              <a:t>7/2/26</a:t>
+              <a:t>7/7/26</a:t>
             </a:fld>
             <a:endParaRPr lang="en-US"/>
           </a:p>
@@ -1008,7 +1008,7 @@
           <a:p>
             <a:fld id="{5BCAD085-E8A6-8845-BD4E-CB4CCA059FC4}" type="datetimeFigureOut">
               <a:rPr lang="en-US" smtClean="0"/>
-              <a:t>7/2/26</a:t>
+              <a:t>7/7/26</a:t>
             </a:fld>
             <a:endParaRPr lang="en-US"/>
           </a:p>
@@ -1176,7 +1176,7 @@
           <a:p>
             <a:fld id="{5BCAD085-E8A6-8845-BD4E-CB4CCA059FC4}" type="datetimeFigureOut">
               <a:rPr lang="en-US" smtClean="0"/>
-              <a:t>7/2/26</a:t>
+              <a:t>7/7/26</a:t>
             </a:fld>
             <a:endParaRPr lang="en-US"/>
           </a:p>
@@ -1421,7 +1421,7 @@
           <a:p>
             <a:fld id="{5BCAD085-E8A6-8845-BD4E-CB4CCA059FC4}" type="datetimeFigureOut">
               <a:rPr lang="en-US" smtClean="0"/>
-              <a:t>7/2/26</a:t>
+              <a:t>7/7/26</a:t>
             </a:fld>
             <a:endParaRPr lang="en-US"/>
           </a:p>
@@ -1706,7 +1706,7 @@
           <a:p>
             <a:fld id="{5BCAD085-E8A6-8845-BD4E-CB4CCA059FC4}" type="datetimeFigureOut">
               <a:rPr lang="en-US" smtClean="0"/>
-              <a:t>7/2/26</a:t>
+              <a:t>7/7/26</a:t>
             </a:fld>
             <a:endParaRPr lang="en-US"/>
           </a:p>
@@ -2125,7 +2125,7 @@
           <a:p>
             <a:fld id="{5BCAD085-E8A6-8845-BD4E-CB4CCA059FC4}" type="datetimeFigureOut">
               <a:rPr lang="en-US" smtClean="0"/>
-              <a:t>7/2/26</a:t>
+              <a:t>7/7/26</a:t>
             </a:fld>
             <a:endParaRPr lang="en-US"/>
           </a:p>
@@ -2242,7 +2242,7 @@
           <a:p>
             <a:fld id="{5BCAD085-E8A6-8845-BD4E-CB4CCA059FC4}" type="datetimeFigureOut">
               <a:rPr lang="en-US" smtClean="0"/>
-              <a:t>7/2/26</a:t>
+              <a:t>7/7/26</a:t>
             </a:fld>
             <a:endParaRPr lang="en-US"/>
           </a:p>
@@ -2337,7 +2337,7 @@
           <a:p>
             <a:fld id="{5BCAD085-E8A6-8845-BD4E-CB4CCA059FC4}" type="datetimeFigureOut">
               <a:rPr lang="en-US" smtClean="0"/>
-              <a:t>7/2/26</a:t>
+              <a:t>7/7/26</a:t>
             </a:fld>
             <a:endParaRPr lang="en-US"/>
           </a:p>
@@ -2612,7 +2612,7 @@
           <a:p>
             <a:fld id="{5BCAD085-E8A6-8845-BD4E-CB4CCA059FC4}" type="datetimeFigureOut">
               <a:rPr lang="en-US" smtClean="0"/>
-              <a:t>7/2/26</a:t>
+              <a:t>7/7/26</a:t>
             </a:fld>
             <a:endParaRPr lang="en-US"/>
           </a:p>
@@ -2864,7 +2864,7 @@
           <a:p>
             <a:fld id="{5BCAD085-E8A6-8845-BD4E-CB4CCA059FC4}" type="datetimeFigureOut">
               <a:rPr lang="en-US" smtClean="0"/>
-              <a:t>7/2/26</a:t>
+              <a:t>7/7/26</a:t>
             </a:fld>
             <a:endParaRPr lang="en-US"/>
           </a:p>
@@ -3075,7 +3075,7 @@
           <a:p>
             <a:fld id="{5BCAD085-E8A6-8845-BD4E-CB4CCA059FC4}" type="datetimeFigureOut">
               <a:rPr lang="en-US" smtClean="0"/>
-              <a:t>7/2/26</a:t>
+              <a:t>7/7/26</a:t>
             </a:fld>
             <a:endParaRPr lang="en-US"/>
           </a:p>
@@ -4960,49 +4960,6 @@
       </p:grpSpPr>
       <p:sp>
         <p:nvSpPr>
-          <p:cNvPr id="67" name="ZoneTexte 66">
-            <a:extLst>
-              <a:ext uri="{FF2B5EF4-FFF2-40B4-BE49-F238E27FC236}">
-                <a16:creationId xmlns:a16="http://schemas.microsoft.com/office/drawing/2014/main" id="{243CB846-14FC-4C46-B83E-0B443436468B}"/>
-              </a:ext>
-            </a:extLst>
-          </p:cNvPr>
-          <p:cNvSpPr txBox="1"/>
-          <p:nvPr/>
-        </p:nvSpPr>
-        <p:spPr>
-          <a:xfrm>
-            <a:off x="3421848" y="5431356"/>
-            <a:ext cx="2764190" cy="262800"/>
-          </a:xfrm>
-          <a:prstGeom prst="rect">
-            <a:avLst/>
-          </a:prstGeom>
-          <a:noFill/>
-        </p:spPr>
-        <p:txBody>
-          <a:bodyPr wrap="square" rtlCol="0">
-            <a:spAutoFit/>
-          </a:bodyPr>
-          <a:lstStyle/>
-          <a:p>
-            <a:pPr algn="ctr"/>
-            <a:r>
-              <a:rPr lang="fr-FR" sz="1100" b="1" dirty="0">
-                <a:solidFill>
-                  <a:schemeClr val="bg1"/>
-                </a:solidFill>
-                <a:latin typeface="Noto Sans" panose="020B0502040504020204" pitchFamily="34" charset="0"/>
-                <a:ea typeface="Noto Sans" panose="020B0502040504020204" pitchFamily="34" charset="0"/>
-                <a:cs typeface="Noto Sans" panose="020B0502040504020204" pitchFamily="34" charset="0"/>
-              </a:rPr>
-              <a:t>{{P4_TERRAIN}}</a:t>
-            </a:r>
-          </a:p>
-        </p:txBody>
-      </p:sp>
-      <p:sp>
-        <p:nvSpPr>
           <p:cNvPr id="62" name="Rounded Rectangle 2">
             <a:extLst>
               <a:ext uri="{FF2B5EF4-FFF2-40B4-BE49-F238E27FC236}">
@@ -5264,6 +5221,49 @@
               <a:defRPr sz="1000"/>
             </a:pPr>
             <a:endParaRPr sz="907" dirty="0"/>
+          </a:p>
+        </p:txBody>
+      </p:sp>
+      <p:sp>
+        <p:nvSpPr>
+          <p:cNvPr id="67" name="ZoneTexte 66">
+            <a:extLst>
+              <a:ext uri="{FF2B5EF4-FFF2-40B4-BE49-F238E27FC236}">
+                <a16:creationId xmlns:a16="http://schemas.microsoft.com/office/drawing/2014/main" id="{243CB846-14FC-4C46-B83E-0B443436468B}"/>
+              </a:ext>
+            </a:extLst>
+          </p:cNvPr>
+          <p:cNvSpPr txBox="1"/>
+          <p:nvPr/>
+        </p:nvSpPr>
+        <p:spPr>
+          <a:xfrm>
+            <a:off x="3421848" y="5431356"/>
+            <a:ext cx="2764190" cy="262800"/>
+          </a:xfrm>
+          <a:prstGeom prst="rect">
+            <a:avLst/>
+          </a:prstGeom>
+          <a:noFill/>
+        </p:spPr>
+        <p:txBody>
+          <a:bodyPr wrap="square" rtlCol="0">
+            <a:spAutoFit/>
+          </a:bodyPr>
+          <a:lstStyle/>
+          <a:p>
+            <a:pPr algn="ctr"/>
+            <a:r>
+              <a:rPr lang="fr-FR" sz="1100" b="1" dirty="0">
+                <a:solidFill>
+                  <a:schemeClr val="bg1"/>
+                </a:solidFill>
+                <a:latin typeface="Noto Sans" panose="020B0502040504020204" pitchFamily="34" charset="0"/>
+                <a:ea typeface="Noto Sans" panose="020B0502040504020204" pitchFamily="34" charset="0"/>
+                <a:cs typeface="Noto Sans" panose="020B0502040504020204" pitchFamily="34" charset="0"/>
+              </a:rPr>
+              <a:t>{{P4_TERRAIN}}</a:t>
+            </a:r>
           </a:p>
         </p:txBody>
       </p:sp>

</xml_diff>

<commit_message>
chore(templates): mise en page templates bleus (bannieres bleues encarts matchs)
Synchronise les 12 templates modifies depuis feature/manager pour Engine en prod.

Co-authored-by: Cursor <cursoragent@cursor.com>
</commit_message>
<xml_diff>
--- a/templates bleus/Template_12_1J.pptx
+++ b/templates bleus/Template_12_1J.pptx
@@ -216,7 +216,7 @@
           <a:p>
             <a:fld id="{7758DB49-402F-FB41-B58E-980CBE386162}" type="datetimeFigureOut">
               <a:rPr lang="fr-FR" smtClean="0"/>
-              <a:t>02/07/2026</a:t>
+              <a:t>07/07/2026</a:t>
             </a:fld>
             <a:endParaRPr lang="fr-FR"/>
           </a:p>
@@ -662,7 +662,7 @@
           <a:p>
             <a:fld id="{5BCAD085-E8A6-8845-BD4E-CB4CCA059FC4}" type="datetimeFigureOut">
               <a:rPr lang="en-US" smtClean="0"/>
-              <a:t>7/2/26</a:t>
+              <a:t>7/7/26</a:t>
             </a:fld>
             <a:endParaRPr lang="en-US"/>
           </a:p>
@@ -830,7 +830,7 @@
           <a:p>
             <a:fld id="{5BCAD085-E8A6-8845-BD4E-CB4CCA059FC4}" type="datetimeFigureOut">
               <a:rPr lang="en-US" smtClean="0"/>
-              <a:t>7/2/26</a:t>
+              <a:t>7/7/26</a:t>
             </a:fld>
             <a:endParaRPr lang="en-US"/>
           </a:p>
@@ -1008,7 +1008,7 @@
           <a:p>
             <a:fld id="{5BCAD085-E8A6-8845-BD4E-CB4CCA059FC4}" type="datetimeFigureOut">
               <a:rPr lang="en-US" smtClean="0"/>
-              <a:t>7/2/26</a:t>
+              <a:t>7/7/26</a:t>
             </a:fld>
             <a:endParaRPr lang="en-US"/>
           </a:p>
@@ -1176,7 +1176,7 @@
           <a:p>
             <a:fld id="{5BCAD085-E8A6-8845-BD4E-CB4CCA059FC4}" type="datetimeFigureOut">
               <a:rPr lang="en-US" smtClean="0"/>
-              <a:t>7/2/26</a:t>
+              <a:t>7/7/26</a:t>
             </a:fld>
             <a:endParaRPr lang="en-US"/>
           </a:p>
@@ -1421,7 +1421,7 @@
           <a:p>
             <a:fld id="{5BCAD085-E8A6-8845-BD4E-CB4CCA059FC4}" type="datetimeFigureOut">
               <a:rPr lang="en-US" smtClean="0"/>
-              <a:t>7/2/26</a:t>
+              <a:t>7/7/26</a:t>
             </a:fld>
             <a:endParaRPr lang="en-US"/>
           </a:p>
@@ -1706,7 +1706,7 @@
           <a:p>
             <a:fld id="{5BCAD085-E8A6-8845-BD4E-CB4CCA059FC4}" type="datetimeFigureOut">
               <a:rPr lang="en-US" smtClean="0"/>
-              <a:t>7/2/26</a:t>
+              <a:t>7/7/26</a:t>
             </a:fld>
             <a:endParaRPr lang="en-US"/>
           </a:p>
@@ -2125,7 +2125,7 @@
           <a:p>
             <a:fld id="{5BCAD085-E8A6-8845-BD4E-CB4CCA059FC4}" type="datetimeFigureOut">
               <a:rPr lang="en-US" smtClean="0"/>
-              <a:t>7/2/26</a:t>
+              <a:t>7/7/26</a:t>
             </a:fld>
             <a:endParaRPr lang="en-US"/>
           </a:p>
@@ -2242,7 +2242,7 @@
           <a:p>
             <a:fld id="{5BCAD085-E8A6-8845-BD4E-CB4CCA059FC4}" type="datetimeFigureOut">
               <a:rPr lang="en-US" smtClean="0"/>
-              <a:t>7/2/26</a:t>
+              <a:t>7/7/26</a:t>
             </a:fld>
             <a:endParaRPr lang="en-US"/>
           </a:p>
@@ -2337,7 +2337,7 @@
           <a:p>
             <a:fld id="{5BCAD085-E8A6-8845-BD4E-CB4CCA059FC4}" type="datetimeFigureOut">
               <a:rPr lang="en-US" smtClean="0"/>
-              <a:t>7/2/26</a:t>
+              <a:t>7/7/26</a:t>
             </a:fld>
             <a:endParaRPr lang="en-US"/>
           </a:p>
@@ -2612,7 +2612,7 @@
           <a:p>
             <a:fld id="{5BCAD085-E8A6-8845-BD4E-CB4CCA059FC4}" type="datetimeFigureOut">
               <a:rPr lang="en-US" smtClean="0"/>
-              <a:t>7/2/26</a:t>
+              <a:t>7/7/26</a:t>
             </a:fld>
             <a:endParaRPr lang="en-US"/>
           </a:p>
@@ -2864,7 +2864,7 @@
           <a:p>
             <a:fld id="{5BCAD085-E8A6-8845-BD4E-CB4CCA059FC4}" type="datetimeFigureOut">
               <a:rPr lang="en-US" smtClean="0"/>
-              <a:t>7/2/26</a:t>
+              <a:t>7/7/26</a:t>
             </a:fld>
             <a:endParaRPr lang="en-US"/>
           </a:p>
@@ -3075,7 +3075,7 @@
           <a:p>
             <a:fld id="{5BCAD085-E8A6-8845-BD4E-CB4CCA059FC4}" type="datetimeFigureOut">
               <a:rPr lang="en-US" smtClean="0"/>
-              <a:t>7/2/26</a:t>
+              <a:t>7/7/26</a:t>
             </a:fld>
             <a:endParaRPr lang="en-US"/>
           </a:p>
@@ -4960,49 +4960,6 @@
       </p:grpSpPr>
       <p:sp>
         <p:nvSpPr>
-          <p:cNvPr id="67" name="ZoneTexte 66">
-            <a:extLst>
-              <a:ext uri="{FF2B5EF4-FFF2-40B4-BE49-F238E27FC236}">
-                <a16:creationId xmlns:a16="http://schemas.microsoft.com/office/drawing/2014/main" id="{243CB846-14FC-4C46-B83E-0B443436468B}"/>
-              </a:ext>
-            </a:extLst>
-          </p:cNvPr>
-          <p:cNvSpPr txBox="1"/>
-          <p:nvPr/>
-        </p:nvSpPr>
-        <p:spPr>
-          <a:xfrm>
-            <a:off x="3421848" y="5431356"/>
-            <a:ext cx="2764190" cy="262800"/>
-          </a:xfrm>
-          <a:prstGeom prst="rect">
-            <a:avLst/>
-          </a:prstGeom>
-          <a:noFill/>
-        </p:spPr>
-        <p:txBody>
-          <a:bodyPr wrap="square" rtlCol="0">
-            <a:spAutoFit/>
-          </a:bodyPr>
-          <a:lstStyle/>
-          <a:p>
-            <a:pPr algn="ctr"/>
-            <a:r>
-              <a:rPr lang="fr-FR" sz="1100" b="1" dirty="0">
-                <a:solidFill>
-                  <a:schemeClr val="bg1"/>
-                </a:solidFill>
-                <a:latin typeface="Noto Sans" panose="020B0502040504020204" pitchFamily="34" charset="0"/>
-                <a:ea typeface="Noto Sans" panose="020B0502040504020204" pitchFamily="34" charset="0"/>
-                <a:cs typeface="Noto Sans" panose="020B0502040504020204" pitchFamily="34" charset="0"/>
-              </a:rPr>
-              <a:t>{{P4_TERRAIN}}</a:t>
-            </a:r>
-          </a:p>
-        </p:txBody>
-      </p:sp>
-      <p:sp>
-        <p:nvSpPr>
           <p:cNvPr id="62" name="Rounded Rectangle 2">
             <a:extLst>
               <a:ext uri="{FF2B5EF4-FFF2-40B4-BE49-F238E27FC236}">
@@ -5264,6 +5221,49 @@
               <a:defRPr sz="1000"/>
             </a:pPr>
             <a:endParaRPr sz="907" dirty="0"/>
+          </a:p>
+        </p:txBody>
+      </p:sp>
+      <p:sp>
+        <p:nvSpPr>
+          <p:cNvPr id="67" name="ZoneTexte 66">
+            <a:extLst>
+              <a:ext uri="{FF2B5EF4-FFF2-40B4-BE49-F238E27FC236}">
+                <a16:creationId xmlns:a16="http://schemas.microsoft.com/office/drawing/2014/main" id="{243CB846-14FC-4C46-B83E-0B443436468B}"/>
+              </a:ext>
+            </a:extLst>
+          </p:cNvPr>
+          <p:cNvSpPr txBox="1"/>
+          <p:nvPr/>
+        </p:nvSpPr>
+        <p:spPr>
+          <a:xfrm>
+            <a:off x="3421848" y="5431356"/>
+            <a:ext cx="2764190" cy="262800"/>
+          </a:xfrm>
+          <a:prstGeom prst="rect">
+            <a:avLst/>
+          </a:prstGeom>
+          <a:noFill/>
+        </p:spPr>
+        <p:txBody>
+          <a:bodyPr wrap="square" rtlCol="0">
+            <a:spAutoFit/>
+          </a:bodyPr>
+          <a:lstStyle/>
+          <a:p>
+            <a:pPr algn="ctr"/>
+            <a:r>
+              <a:rPr lang="fr-FR" sz="1100" b="1" dirty="0">
+                <a:solidFill>
+                  <a:schemeClr val="bg1"/>
+                </a:solidFill>
+                <a:latin typeface="Noto Sans" panose="020B0502040504020204" pitchFamily="34" charset="0"/>
+                <a:ea typeface="Noto Sans" panose="020B0502040504020204" pitchFamily="34" charset="0"/>
+                <a:cs typeface="Noto Sans" panose="020B0502040504020204" pitchFamily="34" charset="0"/>
+              </a:rPr>
+              <a:t>{{P4_TERRAIN}}</a:t>
+            </a:r>
           </a:p>
         </p:txBody>
       </p:sp>

</xml_diff>